<commit_message>
Edificio Ciudad Nueva: año de construcción 1990 y retiro del WEB ID (D-102)
- WEB ID retirado de portada, condiciones, aviso legal, Excel y respuestas del asesor
  (barrido de PPTX con notas, PDF y Excel: 0 coincidencias)
- D-102: el WEB ID es interno (identifica al captador) y nunca va en piezas para clientes
- Año de construcción 1990 (36 años) en portada, resumen, superficies, condiciones y riesgos

Co-Authored-By: Claude Opus 5.5 <noreply@anthropic.com>
Claude-Session: https://claude.ai/code/session_01Gncsby71g9SW8JZEc88cEa
</commit_message>
<xml_diff>
--- a/projects/edificio-ciudad-nueva/entregables/Edificio_Ciudad_Nueva_Meridiano_FINAL.pptx
+++ b/projects/edificio-ciudad-nueva/entregables/Edificio_Ciudad_Nueva_Meridiano_FINAL.pptx
@@ -3482,7 +3482,7 @@
                 <a:ea typeface="Poppins" pitchFamily="34" charset="-122"/>
                 <a:cs typeface="Poppins" pitchFamily="34" charset="-120"/>
               </a:rPr>
-              <a:t>Datos con verificación documental  ·  TC Gs 5.694 (BCP, 09/10/2026)  ·  WEB ID 143028006-118</a:t>
+              <a:t>Construido en 1990  ·  Datos con verificación documental  ·  TC Gs 5.694 (BCP, 09/10/2026)</a:t>
             </a:r>
             <a:endParaRPr lang="en-US" sz="900" dirty="0"/>
           </a:p>
@@ -11141,7 +11141,7 @@
                 <a:ea typeface="Poppins" pitchFamily="34" charset="-122"/>
                 <a:cs typeface="Poppins" pitchFamily="34" charset="-120"/>
               </a:rPr>
-              <a:t>Referencia WEB ID 143028006-118</a:t>
+              <a:t>Edificio construido en 1990</a:t>
             </a:r>
             <a:endParaRPr lang="en-US" sz="1200" dirty="0"/>
           </a:p>
@@ -11354,7 +11354,7 @@
                 <a:ea typeface="Poppins" pitchFamily="34" charset="-122"/>
                 <a:cs typeface="Poppins" pitchFamily="34" charset="-120"/>
               </a:rPr>
-              <a:t>13 departamentos y 1 local comercial, más terraza. 1.109 m² construidos sobre 340 m² de terreno.</a:t>
+              <a:t>13 departamentos y 1 local comercial, más terraza. 1.109 m² construidos en 1990 sobre 340 m² de terreno.</a:t>
             </a:r>
             <a:endParaRPr lang="en-US" sz="1300" dirty="0"/>
           </a:p>
@@ -13320,7 +13320,7 @@
                 <a:ea typeface="Poppins" pitchFamily="34" charset="-122"/>
                 <a:cs typeface="Poppins" pitchFamily="34" charset="-120"/>
               </a:rPr>
-              <a:t>Un edificio de 13 unidades requiere mantenimiento continuo; obras mayores se presupuestan aparte.</a:t>
+              <a:t>Un edificio de 1990 con 13 unidades requiere mantenimiento continuo; la inspección técnica define si conviene actualizar instalaciones o impermeabilización.</a:t>
             </a:r>
             <a:endParaRPr lang="en-US" sz="1200" dirty="0"/>
           </a:p>
@@ -14030,7 +14030,7 @@
                 <a:ea typeface="Poppins" pitchFamily="34" charset="-122"/>
                 <a:cs typeface="Poppins" pitchFamily="34" charset="-120"/>
               </a:rPr>
-              <a:t>Documento comercial de referencia. Precio y condiciones sujetos a confirmación y disponibilidad; las condiciones definitivas se formalizan en el boleto de compraventa. No constituye una garantía de rentabilidad.  ·  WEB ID 143028006-118</a:t>
+              <a:t>Documento comercial de referencia. Precio y condiciones sujetos a confirmación y disponibilidad; las condiciones definitivas se formalizan en el boleto de compraventa. No constituye una garantía de rentabilidad.</a:t>
             </a:r>
             <a:endParaRPr lang="en-US" sz="900" dirty="0"/>
           </a:p>
@@ -14185,7 +14185,7 @@
                 <a:ea typeface="Poppins" pitchFamily="34" charset="-122"/>
                 <a:cs typeface="Poppins" pitchFamily="34" charset="-120"/>
               </a:rPr>
-              <a:t>Activo en operación, 100% alquilado, a una cuadra de la Av. Eusebio Ayala y a pocos minutos a pie del Mercado 4, el principal polo comercial minorista del país.</a:t>
+              <a:t>Edificio construido en 1990, en operación y 100% alquilado, a una cuadra de la Av. Eusebio Ayala y a pocos minutos a pie del Mercado 4, el principal polo comercial minorista del país.</a:t>
             </a:r>
             <a:endParaRPr lang="en-US" sz="1300" dirty="0"/>
           </a:p>
@@ -17054,7 +17054,7 @@
                 <a:ea typeface="Poppins" pitchFamily="34" charset="-122"/>
                 <a:cs typeface="Poppins" pitchFamily="34" charset="-120"/>
               </a:rPr>
-              <a:t>Superficie construida total</a:t>
+              <a:t>Superficie construida  ·  3,3 veces el terreno</a:t>
             </a:r>
             <a:endParaRPr lang="en-US" sz="1050" dirty="0"/>
           </a:p>
@@ -17116,7 +17116,7 @@
                 <a:ea typeface="Fraunces" pitchFamily="34" charset="-122"/>
                 <a:cs typeface="Fraunces" pitchFamily="34" charset="-120"/>
               </a:rPr>
-              <a:t>3,3 veces</a:t>
+              <a:t>1990</a:t>
             </a:r>
             <a:endParaRPr lang="en-US" sz="2400" dirty="0"/>
           </a:p>
@@ -17155,7 +17155,7 @@
                 <a:ea typeface="Poppins" pitchFamily="34" charset="-122"/>
                 <a:cs typeface="Poppins" pitchFamily="34" charset="-120"/>
               </a:rPr>
-              <a:t>Construido sobre la superficie del terreno</a:t>
+              <a:t>Año de construcción  ·  36 años</a:t>
             </a:r>
             <a:endParaRPr lang="en-US" sz="1050" dirty="0"/>
           </a:p>
@@ -17601,7 +17601,7 @@
                 <a:ea typeface="Poppins" pitchFamily="34" charset="-122"/>
                 <a:cs typeface="Poppins" pitchFamily="34" charset="-120"/>
               </a:rPr>
-              <a:t>Referencia del barrio: un edificio de 9 unidades en Ciudad Nueva se publica en USD 650.000 (unos USD 72.222 por unidad). Valores de referencia, no tasación: el edificio es usado y el costo de construcción nueva no descuenta antigüedad.</a:t>
+              <a:t>Referencia del barrio: un edificio de 9 unidades en Ciudad Nueva se publica en USD 650.000 (unos USD 72.222 por unidad). Valores de referencia, no tasación: el costo de construcción nueva no descuenta los 36 años del edificio ni su estado de conservación.</a:t>
             </a:r>
             <a:endParaRPr lang="en-US" sz="950" dirty="0"/>
           </a:p>

</xml_diff>